<commit_message>
Story cards: move accent bar below the title
Co-Authored-By: Claude Opus 5.5 <noreply@anthropic.com>
Claude-Session: https://claude.ai/code/session_01RnMzsxqDMfgar4HrYCdSBS
</commit_message>
<xml_diff>
--- a/templates/08-stories-editable.pptx
+++ b/templates/08-stories-editable.pptx
@@ -3279,7 +3279,7 @@
         </p:nvSpPr>
         <p:spPr>
           <a:xfrm>
-            <a:off x="857250" y="13182600"/>
+            <a:off x="857250" y="13639800"/>
             <a:ext cx="2286000" cy="133350"/>
           </a:xfrm>
           <a:prstGeom prst="rect">
@@ -3323,7 +3323,7 @@
         </p:nvSpPr>
         <p:spPr>
           <a:xfrm>
-            <a:off x="857250" y="13658850"/>
+            <a:off x="857250" y="14116050"/>
             <a:ext cx="8572500" cy="1333500"/>
           </a:xfrm>
           <a:prstGeom prst="rect">
@@ -3599,7 +3599,7 @@
         </p:nvSpPr>
         <p:spPr>
           <a:xfrm>
-            <a:off x="857250" y="12715875"/>
+            <a:off x="857250" y="13087350"/>
             <a:ext cx="2286000" cy="133350"/>
           </a:xfrm>
           <a:prstGeom prst="rect">
@@ -3643,7 +3643,7 @@
         </p:nvSpPr>
         <p:spPr>
           <a:xfrm>
-            <a:off x="857250" y="13192125"/>
+            <a:off x="857250" y="13563600"/>
             <a:ext cx="8572500" cy="1333500"/>
           </a:xfrm>
           <a:prstGeom prst="rect">
@@ -3935,7 +3935,7 @@
         </p:nvSpPr>
         <p:spPr>
           <a:xfrm>
-            <a:off x="857250" y="14354175"/>
+            <a:off x="857250" y="15039975"/>
             <a:ext cx="2286000" cy="133350"/>
           </a:xfrm>
           <a:prstGeom prst="rect">
@@ -3979,7 +3979,7 @@
         </p:nvSpPr>
         <p:spPr>
           <a:xfrm>
-            <a:off x="857250" y="14830425"/>
+            <a:off x="857250" y="15516225"/>
             <a:ext cx="8572500" cy="1333500"/>
           </a:xfrm>
           <a:prstGeom prst="rect">
@@ -4255,7 +4255,7 @@
         </p:nvSpPr>
         <p:spPr>
           <a:xfrm>
-            <a:off x="857250" y="13182600"/>
+            <a:off x="857250" y="13639800"/>
             <a:ext cx="2286000" cy="133350"/>
           </a:xfrm>
           <a:prstGeom prst="rect">
@@ -4299,7 +4299,7 @@
         </p:nvSpPr>
         <p:spPr>
           <a:xfrm>
-            <a:off x="857250" y="13658850"/>
+            <a:off x="857250" y="14116050"/>
             <a:ext cx="8572500" cy="1333500"/>
           </a:xfrm>
           <a:prstGeom prst="rect">
@@ -4591,7 +4591,7 @@
         </p:nvSpPr>
         <p:spPr>
           <a:xfrm>
-            <a:off x="857250" y="14354175"/>
+            <a:off x="857250" y="15039975"/>
             <a:ext cx="2286000" cy="133350"/>
           </a:xfrm>
           <a:prstGeom prst="rect">
@@ -4635,7 +4635,7 @@
         </p:nvSpPr>
         <p:spPr>
           <a:xfrm>
-            <a:off x="857250" y="14830425"/>
+            <a:off x="857250" y="15516225"/>
             <a:ext cx="8572500" cy="1333500"/>
           </a:xfrm>
           <a:prstGeom prst="rect">
@@ -4911,7 +4911,7 @@
         </p:nvSpPr>
         <p:spPr>
           <a:xfrm>
-            <a:off x="857250" y="12715875"/>
+            <a:off x="857250" y="13087350"/>
             <a:ext cx="2286000" cy="133350"/>
           </a:xfrm>
           <a:prstGeom prst="rect">
@@ -4955,7 +4955,7 @@
         </p:nvSpPr>
         <p:spPr>
           <a:xfrm>
-            <a:off x="857250" y="13192125"/>
+            <a:off x="857250" y="13563600"/>
             <a:ext cx="8572500" cy="1333500"/>
           </a:xfrm>
           <a:prstGeom prst="rect">
@@ -5231,7 +5231,7 @@
         </p:nvSpPr>
         <p:spPr>
           <a:xfrm>
-            <a:off x="857250" y="13182600"/>
+            <a:off x="857250" y="13639800"/>
             <a:ext cx="2286000" cy="133350"/>
           </a:xfrm>
           <a:prstGeom prst="rect">
@@ -5275,7 +5275,7 @@
         </p:nvSpPr>
         <p:spPr>
           <a:xfrm>
-            <a:off x="857250" y="13658850"/>
+            <a:off x="857250" y="14116050"/>
             <a:ext cx="8572500" cy="1333500"/>
           </a:xfrm>
           <a:prstGeom prst="rect">
@@ -5551,7 +5551,7 @@
         </p:nvSpPr>
         <p:spPr>
           <a:xfrm>
-            <a:off x="857250" y="13182600"/>
+            <a:off x="857250" y="13639800"/>
             <a:ext cx="2286000" cy="133350"/>
           </a:xfrm>
           <a:prstGeom prst="rect">
@@ -5595,7 +5595,7 @@
         </p:nvSpPr>
         <p:spPr>
           <a:xfrm>
-            <a:off x="857250" y="13658850"/>
+            <a:off x="857250" y="14116050"/>
             <a:ext cx="8572500" cy="1333500"/>
           </a:xfrm>
           <a:prstGeom prst="rect">

</xml_diff>